<commit_message>
feat(diagramas): redisenar como landscape e integrar en PPTX y README
- Redisenar pipeline_flow como layout de dos filas (horizontal, ratio 3.15:1)
- Redisenar cloud_interior como flujo horizontal (Internet→IGW→Nginx→FastAPI, ratio 3.82:1)
- Traducir todas las etiquetas al espanol neutro
- Reemplazar slide 7 de texto por dos slides de imagen (slides 7 y 8)
- Actualizar numeracion de slides de /10 a /11
- Agregar diagramas al README.md con imagenes renderizadas
- Eliminar archivos .excalidraw obsoletos
</commit_message>
<xml_diff>
--- a/presentation/final_presentation.pptx
+++ b/presentation/final_presentation.pptx
@@ -11,7 +11,8 @@
     <p:sldId id="259" r:id="rId11"/>
     <p:sldId id="260" r:id="rId12"/>
     <p:sldId id="261" r:id="rId13"/>
-    <p:sldId id="262" r:id="rId14"/>
+    <p:sldId id="266" r:id="rId18"/>
+    <p:sldId id="267" r:id="rId19"/>
     <p:sldId id="263" r:id="rId15"/>
     <p:sldId id="264" r:id="rId16"/>
     <p:sldId id="265" r:id="rId17"/>
@@ -1017,86 +1018,6 @@
           <a:p>
             <a:r>
               <a:t>Cada paso verde es una garantia.</a:t>
-            </a:r>
-          </a:p>
-        </p:txBody>
-      </p:sp>
-      <p:sp>
-        <p:nvSpPr>
-          <p:cNvPr id="4" name="Slide Number Placeholder 3"/>
-          <p:cNvSpPr>
-            <a:spLocks noGrp="1"/>
-          </p:cNvSpPr>
-          <p:nvPr>
-            <p:ph type="sldNum" idx="5" sz="quarter"/>
-          </p:nvPr>
-        </p:nvSpPr>
-        <p:spPr/>
-      </p:sp>
-    </p:spTree>
-  </p:cSld>
-  <p:clrMapOvr>
-    <a:masterClrMapping/>
-  </p:clrMapOvr>
-</p:notes>
-</file>
-
-<file path=ppt/notesSlides/notesSlide7.xml><?xml version="1.0" encoding="utf-8"?>
-<p:notes xmlns:a="http://schemas.openxmlformats.org/drawingml/2006/main" xmlns:p="http://schemas.openxmlformats.org/presentationml/2006/main" xmlns:r="http://schemas.openxmlformats.org/officeDocument/2006/relationships">
-  <p:cSld>
-    <p:spTree>
-      <p:nvGrpSpPr>
-        <p:cNvPr id="1" name=""/>
-        <p:cNvGrpSpPr/>
-        <p:nvPr/>
-      </p:nvGrpSpPr>
-      <p:grpSpPr>
-        <a:xfrm>
-          <a:off x="0" y="0"/>
-          <a:ext cx="0" cy="0"/>
-          <a:chOff x="0" y="0"/>
-          <a:chExt cx="0" cy="0"/>
-        </a:xfrm>
-      </p:grpSpPr>
-      <p:sp>
-        <p:nvSpPr>
-          <p:cNvPr id="2" name="Slide Image Placeholder 1"/>
-          <p:cNvSpPr>
-            <a:spLocks noGrp="1"/>
-          </p:cNvSpPr>
-          <p:nvPr>
-            <p:ph type="sldImg" idx="2"/>
-          </p:nvPr>
-        </p:nvSpPr>
-        <p:spPr/>
-      </p:sp>
-      <p:sp>
-        <p:nvSpPr>
-          <p:cNvPr id="3" name="Notes Placeholder 2"/>
-          <p:cNvSpPr>
-            <a:spLocks noGrp="1"/>
-          </p:cNvSpPr>
-          <p:nvPr>
-            <p:ph type="body" idx="3" sz="quarter"/>
-          </p:nvPr>
-        </p:nvSpPr>
-        <p:spPr/>
-        <p:txBody>
-          <a:bodyPr/>
-          <a:lstStyle/>
-          <a:p>
-            <a:r>
-              <a:t>[ARQUITECTURA - 5 min]</a:t>
-            </a:r>
-          </a:p>
-          <a:p>
-            <a:r>
-              <a:t>Punto clave: el SG del backend rechaza trafico de internet.</a:t>
-            </a:r>
-          </a:p>
-          <a:p>
-            <a:r>
-              <a:t>Solo acepta trafico del SG del frontend. No es una regla de IP, es una regla de identidad.</a:t>
             </a:r>
           </a:p>
         </p:txBody>
@@ -5060,6 +4981,546 @@
 </p:sld>
 </file>
 
+<file path=ppt/slides/slide11.xml><?xml version="1.0" encoding="utf-8"?>
+<p:sld xmlns:a="http://schemas.openxmlformats.org/drawingml/2006/main" xmlns:p="http://schemas.openxmlformats.org/presentationml/2006/main" xmlns:r="http://schemas.openxmlformats.org/officeDocument/2006/relationships">
+  <p:cSld>
+    <p:spTree>
+      <p:nvGrpSpPr>
+        <p:cNvPr id="1" name=""/>
+        <p:cNvGrpSpPr/>
+        <p:nvPr/>
+      </p:nvGrpSpPr>
+      <p:grpSpPr/>
+      <p:sp>
+        <p:nvSpPr>
+          <p:cNvPr id="2" name="Rectangle 1"/>
+          <p:cNvSpPr/>
+          <p:nvPr/>
+        </p:nvSpPr>
+        <p:spPr>
+          <a:xfrm>
+            <a:off x="0" y="0"/>
+            <a:ext cx="12191695" cy="50292"/>
+          </a:xfrm>
+          <a:prstGeom prst="rect">
+            <a:avLst/>
+          </a:prstGeom>
+          <a:solidFill>
+            <a:srgbClr val="0F766E"/>
+          </a:solidFill>
+          <a:ln>
+            <a:noFill/>
+          </a:ln>
+          <a:effectLst/>
+        </p:spPr>
+        <p:style>
+          <a:lnRef idx="1">
+            <a:schemeClr val="accent1"/>
+          </a:lnRef>
+          <a:fillRef idx="3">
+            <a:schemeClr val="accent1"/>
+          </a:fillRef>
+          <a:effectRef idx="2">
+            <a:schemeClr val="accent1"/>
+          </a:effectRef>
+          <a:fontRef idx="minor">
+            <a:schemeClr val="lt1"/>
+          </a:fontRef>
+        </p:style>
+        <p:txBody>
+          <a:bodyPr rtlCol="0" anchor="ctr"/>
+          <a:lstStyle/>
+          <a:p>
+            <a:pPr algn="ctr"/>
+          </a:p>
+        </p:txBody>
+      </p:sp>
+      <p:sp>
+        <p:nvSpPr>
+          <p:cNvPr id="3" name="TextBox 2"/>
+          <p:cNvSpPr txBox="1"/>
+          <p:nvPr/>
+        </p:nvSpPr>
+        <p:spPr>
+          <a:xfrm>
+            <a:off x="411480" y="6510528"/>
+            <a:ext cx="6400800" cy="274320"/>
+          </a:xfrm>
+          <a:prstGeom prst="rect">
+            <a:avLst/>
+          </a:prstGeom>
+          <a:noFill/>
+        </p:spPr>
+        <p:txBody>
+          <a:bodyPr wrap="square" lIns="45720" rIns="45720" tIns="18288" bIns="18288" anchor="t">
+            <a:spAutoFit/>
+          </a:bodyPr>
+          <a:lstStyle/>
+          <a:p>
+            <a:pPr algn="l"/>
+            <a:r>
+              <a:rPr sz="1000" b="0" i="0">
+                <a:solidFill>
+                  <a:srgbClr val="64748B"/>
+                </a:solidFill>
+                <a:latin typeface="Calibri"/>
+              </a:rPr>
+              <a:t>Bootcamperu  ·  Masterclass CI/CD</a:t>
+            </a:r>
+          </a:p>
+        </p:txBody>
+      </p:sp>
+      <p:sp>
+        <p:nvSpPr>
+          <p:cNvPr id="4" name="TextBox 3"/>
+          <p:cNvSpPr txBox="1"/>
+          <p:nvPr/>
+        </p:nvSpPr>
+        <p:spPr>
+          <a:xfrm>
+            <a:off x="11274552" y="6510528"/>
+            <a:ext cx="548640" cy="274320"/>
+          </a:xfrm>
+          <a:prstGeom prst="rect">
+            <a:avLst/>
+          </a:prstGeom>
+          <a:noFill/>
+        </p:spPr>
+        <p:txBody>
+          <a:bodyPr wrap="square" lIns="45720" rIns="45720" tIns="18288" bIns="18288" anchor="t">
+            <a:spAutoFit/>
+          </a:bodyPr>
+          <a:lstStyle/>
+          <a:p>
+            <a:pPr algn="r"/>
+            <a:r>
+              <a:rPr sz="1000" b="1" i="0">
+                <a:solidFill>
+                  <a:srgbClr val="0F172A"/>
+                </a:solidFill>
+                <a:latin typeface="Calibri"/>
+              </a:rPr>
+              <a:t>7 / 11</a:t>
+            </a:r>
+          </a:p>
+        </p:txBody>
+      </p:sp>
+      <p:sp>
+        <p:nvSpPr>
+          <p:cNvPr id="5" name="Rectangle 4"/>
+          <p:cNvSpPr/>
+          <p:nvPr/>
+        </p:nvSpPr>
+        <p:spPr>
+          <a:xfrm>
+            <a:off x="411480" y="457200"/>
+            <a:ext cx="164592" cy="164592"/>
+          </a:xfrm>
+          <a:prstGeom prst="rect">
+            <a:avLst/>
+          </a:prstGeom>
+          <a:solidFill>
+            <a:srgbClr val="0F766E"/>
+          </a:solidFill>
+          <a:ln>
+            <a:noFill/>
+          </a:ln>
+          <a:effectLst/>
+        </p:spPr>
+        <p:style>
+          <a:lnRef idx="1">
+            <a:schemeClr val="accent1"/>
+          </a:lnRef>
+          <a:fillRef idx="3">
+            <a:schemeClr val="accent1"/>
+          </a:fillRef>
+          <a:effectRef idx="2">
+            <a:schemeClr val="accent1"/>
+          </a:effectRef>
+          <a:fontRef idx="minor">
+            <a:schemeClr val="lt1"/>
+          </a:fontRef>
+        </p:style>
+        <p:txBody>
+          <a:bodyPr rtlCol="0" anchor="ctr"/>
+          <a:lstStyle/>
+          <a:p>
+            <a:pPr algn="ctr"/>
+          </a:p>
+        </p:txBody>
+      </p:sp>
+      <p:sp>
+        <p:nvSpPr>
+          <p:cNvPr id="6" name="TextBox 5"/>
+          <p:cNvSpPr txBox="1"/>
+          <p:nvPr/>
+        </p:nvSpPr>
+        <p:spPr>
+          <a:xfrm>
+            <a:off x="685800" y="365760"/>
+            <a:ext cx="10972800" cy="365760"/>
+          </a:xfrm>
+          <a:prstGeom prst="rect">
+            <a:avLst/>
+          </a:prstGeom>
+          <a:noFill/>
+        </p:spPr>
+        <p:txBody>
+          <a:bodyPr wrap="square" lIns="45720" rIns="45720" tIns="18288" bIns="18288" anchor="t">
+            <a:spAutoFit/>
+          </a:bodyPr>
+          <a:lstStyle/>
+          <a:p>
+            <a:pPr algn="l"/>
+            <a:r>
+              <a:rPr sz="1300" b="1" i="0">
+                <a:solidFill>
+                  <a:srgbClr val="0F766E"/>
+                </a:solidFill>
+                <a:latin typeface="Calibri"/>
+              </a:rPr>
+              <a:t>ARQUITECTURA  ·  FLUJO DEL PIPELINE</a:t>
+            </a:r>
+          </a:p>
+        </p:txBody>
+      </p:sp>
+      <p:sp>
+        <p:nvSpPr>
+          <p:cNvPr id="7" name="TextBox 6"/>
+          <p:cNvSpPr txBox="1"/>
+          <p:nvPr/>
+        </p:nvSpPr>
+        <p:spPr>
+          <a:xfrm>
+            <a:off x="411480" y="777240"/>
+            <a:ext cx="11338560" cy="914400"/>
+          </a:xfrm>
+          <a:prstGeom prst="rect">
+            <a:avLst/>
+          </a:prstGeom>
+          <a:noFill/>
+        </p:spPr>
+        <p:txBody>
+          <a:bodyPr wrap="square" lIns="45720" rIns="45720" tIns="18288" bIns="18288" anchor="t">
+            <a:spAutoFit/>
+          </a:bodyPr>
+          <a:lstStyle/>
+          <a:p>
+            <a:pPr algn="l"/>
+            <a:r>
+              <a:rPr sz="3600" b="1" i="0">
+                <a:solidFill>
+                  <a:srgbClr val="0F172A"/>
+                </a:solidFill>
+                <a:latin typeface="Cambria"/>
+              </a:rPr>
+              <a:t>¿Como Llega el Codigo a Produccion?</a:t>
+            </a:r>
+          </a:p>
+        </p:txBody>
+      </p:sp>
+      <p:pic>
+        <p:nvPicPr>
+          <p:cNvPr id="8" name="Picture 7" descr="pipeline_flow.png"/>
+          <p:cNvPicPr>
+            <a:picLocks noChangeAspect="1"/>
+          </p:cNvPicPr>
+          <p:nvPr/>
+        </p:nvPicPr>
+        <p:blipFill>
+          <a:blip r:embed="rId2"/>
+          <a:stretch>
+            <a:fillRect/>
+          </a:stretch>
+        </p:blipFill>
+        <p:spPr>
+          <a:xfrm>
+            <a:off x="612648" y="2331720"/>
+            <a:ext cx="10972800" cy="3483864"/>
+          </a:xfrm>
+          <a:prstGeom prst="rect">
+            <a:avLst/>
+          </a:prstGeom>
+        </p:spPr>
+      </p:pic>
+    </p:spTree>
+  </p:cSld>
+  <p:clrMapOvr>
+    <a:masterClrMapping/>
+  </p:clrMapOvr>
+</p:sld>
+</file>
+
+<file path=ppt/slides/slide12.xml><?xml version="1.0" encoding="utf-8"?>
+<p:sld xmlns:a="http://schemas.openxmlformats.org/drawingml/2006/main" xmlns:p="http://schemas.openxmlformats.org/presentationml/2006/main" xmlns:r="http://schemas.openxmlformats.org/officeDocument/2006/relationships">
+  <p:cSld>
+    <p:spTree>
+      <p:nvGrpSpPr>
+        <p:cNvPr id="1" name=""/>
+        <p:cNvGrpSpPr/>
+        <p:nvPr/>
+      </p:nvGrpSpPr>
+      <p:grpSpPr/>
+      <p:sp>
+        <p:nvSpPr>
+          <p:cNvPr id="2" name="Rectangle 1"/>
+          <p:cNvSpPr/>
+          <p:nvPr/>
+        </p:nvSpPr>
+        <p:spPr>
+          <a:xfrm>
+            <a:off x="0" y="0"/>
+            <a:ext cx="12191695" cy="50292"/>
+          </a:xfrm>
+          <a:prstGeom prst="rect">
+            <a:avLst/>
+          </a:prstGeom>
+          <a:solidFill>
+            <a:srgbClr val="0F766E"/>
+          </a:solidFill>
+          <a:ln>
+            <a:noFill/>
+          </a:ln>
+          <a:effectLst/>
+        </p:spPr>
+        <p:style>
+          <a:lnRef idx="1">
+            <a:schemeClr val="accent1"/>
+          </a:lnRef>
+          <a:fillRef idx="3">
+            <a:schemeClr val="accent1"/>
+          </a:fillRef>
+          <a:effectRef idx="2">
+            <a:schemeClr val="accent1"/>
+          </a:effectRef>
+          <a:fontRef idx="minor">
+            <a:schemeClr val="lt1"/>
+          </a:fontRef>
+        </p:style>
+        <p:txBody>
+          <a:bodyPr rtlCol="0" anchor="ctr"/>
+          <a:lstStyle/>
+          <a:p>
+            <a:pPr algn="ctr"/>
+          </a:p>
+        </p:txBody>
+      </p:sp>
+      <p:sp>
+        <p:nvSpPr>
+          <p:cNvPr id="3" name="TextBox 2"/>
+          <p:cNvSpPr txBox="1"/>
+          <p:nvPr/>
+        </p:nvSpPr>
+        <p:spPr>
+          <a:xfrm>
+            <a:off x="411480" y="6510528"/>
+            <a:ext cx="6400800" cy="274320"/>
+          </a:xfrm>
+          <a:prstGeom prst="rect">
+            <a:avLst/>
+          </a:prstGeom>
+          <a:noFill/>
+        </p:spPr>
+        <p:txBody>
+          <a:bodyPr wrap="square" lIns="45720" rIns="45720" tIns="18288" bIns="18288" anchor="t">
+            <a:spAutoFit/>
+          </a:bodyPr>
+          <a:lstStyle/>
+          <a:p>
+            <a:pPr algn="l"/>
+            <a:r>
+              <a:rPr sz="1000" b="0" i="0">
+                <a:solidFill>
+                  <a:srgbClr val="64748B"/>
+                </a:solidFill>
+                <a:latin typeface="Calibri"/>
+              </a:rPr>
+              <a:t>Bootcamperu  ·  Masterclass CI/CD</a:t>
+            </a:r>
+          </a:p>
+        </p:txBody>
+      </p:sp>
+      <p:sp>
+        <p:nvSpPr>
+          <p:cNvPr id="4" name="TextBox 3"/>
+          <p:cNvSpPr txBox="1"/>
+          <p:nvPr/>
+        </p:nvSpPr>
+        <p:spPr>
+          <a:xfrm>
+            <a:off x="11274552" y="6510528"/>
+            <a:ext cx="548640" cy="274320"/>
+          </a:xfrm>
+          <a:prstGeom prst="rect">
+            <a:avLst/>
+          </a:prstGeom>
+          <a:noFill/>
+        </p:spPr>
+        <p:txBody>
+          <a:bodyPr wrap="square" lIns="45720" rIns="45720" tIns="18288" bIns="18288" anchor="t">
+            <a:spAutoFit/>
+          </a:bodyPr>
+          <a:lstStyle/>
+          <a:p>
+            <a:pPr algn="r"/>
+            <a:r>
+              <a:rPr sz="1000" b="1" i="0">
+                <a:solidFill>
+                  <a:srgbClr val="0F172A"/>
+                </a:solidFill>
+                <a:latin typeface="Calibri"/>
+              </a:rPr>
+              <a:t>8 / 11</a:t>
+            </a:r>
+          </a:p>
+        </p:txBody>
+      </p:sp>
+      <p:sp>
+        <p:nvSpPr>
+          <p:cNvPr id="5" name="Rectangle 4"/>
+          <p:cNvSpPr/>
+          <p:nvPr/>
+        </p:nvSpPr>
+        <p:spPr>
+          <a:xfrm>
+            <a:off x="411480" y="457200"/>
+            <a:ext cx="164592" cy="164592"/>
+          </a:xfrm>
+          <a:prstGeom prst="rect">
+            <a:avLst/>
+          </a:prstGeom>
+          <a:solidFill>
+            <a:srgbClr val="0F766E"/>
+          </a:solidFill>
+          <a:ln>
+            <a:noFill/>
+          </a:ln>
+          <a:effectLst/>
+        </p:spPr>
+        <p:style>
+          <a:lnRef idx="1">
+            <a:schemeClr val="accent1"/>
+          </a:lnRef>
+          <a:fillRef idx="3">
+            <a:schemeClr val="accent1"/>
+          </a:fillRef>
+          <a:effectRef idx="2">
+            <a:schemeClr val="accent1"/>
+          </a:effectRef>
+          <a:fontRef idx="minor">
+            <a:schemeClr val="lt1"/>
+          </a:fontRef>
+        </p:style>
+        <p:txBody>
+          <a:bodyPr rtlCol="0" anchor="ctr"/>
+          <a:lstStyle/>
+          <a:p>
+            <a:pPr algn="ctr"/>
+          </a:p>
+        </p:txBody>
+      </p:sp>
+      <p:sp>
+        <p:nvSpPr>
+          <p:cNvPr id="6" name="TextBox 5"/>
+          <p:cNvSpPr txBox="1"/>
+          <p:nvPr/>
+        </p:nvSpPr>
+        <p:spPr>
+          <a:xfrm>
+            <a:off x="685800" y="365760"/>
+            <a:ext cx="10972800" cy="365760"/>
+          </a:xfrm>
+          <a:prstGeom prst="rect">
+            <a:avLst/>
+          </a:prstGeom>
+          <a:noFill/>
+        </p:spPr>
+        <p:txBody>
+          <a:bodyPr wrap="square" lIns="45720" rIns="45720" tIns="18288" bIns="18288" anchor="t">
+            <a:spAutoFit/>
+          </a:bodyPr>
+          <a:lstStyle/>
+          <a:p>
+            <a:pPr algn="l"/>
+            <a:r>
+              <a:rPr sz="1300" b="1" i="0">
+                <a:solidFill>
+                  <a:srgbClr val="0F766E"/>
+                </a:solidFill>
+                <a:latin typeface="Calibri"/>
+              </a:rPr>
+              <a:t>ARQUITECTURA  ·  RED INTERIOR AWS</a:t>
+            </a:r>
+          </a:p>
+        </p:txBody>
+      </p:sp>
+      <p:sp>
+        <p:nvSpPr>
+          <p:cNvPr id="7" name="TextBox 6"/>
+          <p:cNvSpPr txBox="1"/>
+          <p:nvPr/>
+        </p:nvSpPr>
+        <p:spPr>
+          <a:xfrm>
+            <a:off x="411480" y="777240"/>
+            <a:ext cx="11338560" cy="914400"/>
+          </a:xfrm>
+          <a:prstGeom prst="rect">
+            <a:avLst/>
+          </a:prstGeom>
+          <a:noFill/>
+        </p:spPr>
+        <p:txBody>
+          <a:bodyPr wrap="square" lIns="45720" rIns="45720" tIns="18288" bIns="18288" anchor="t">
+            <a:spAutoFit/>
+          </a:bodyPr>
+          <a:lstStyle/>
+          <a:p>
+            <a:pPr algn="l"/>
+            <a:r>
+              <a:rPr sz="3600" b="1" i="0">
+                <a:solidFill>
+                  <a:srgbClr val="0F172A"/>
+                </a:solidFill>
+                <a:latin typeface="Cambria"/>
+              </a:rPr>
+              <a:t>¿Que Construyo el Robot en AWS?</a:t>
+            </a:r>
+          </a:p>
+        </p:txBody>
+      </p:sp>
+      <p:pic>
+        <p:nvPicPr>
+          <p:cNvPr id="8" name="Picture 7" descr="cloud_interior.png"/>
+          <p:cNvPicPr>
+            <a:picLocks noChangeAspect="1"/>
+          </p:cNvPicPr>
+          <p:nvPr/>
+        </p:nvPicPr>
+        <p:blipFill>
+          <a:blip r:embed="rId2"/>
+          <a:stretch>
+            <a:fillRect/>
+          </a:stretch>
+        </p:blipFill>
+        <p:spPr>
+          <a:xfrm>
+            <a:off x="612648" y="2606040"/>
+            <a:ext cx="10972800" cy="2871216"/>
+          </a:xfrm>
+          <a:prstGeom prst="rect">
+            <a:avLst/>
+          </a:prstGeom>
+        </p:spPr>
+      </p:pic>
+    </p:spTree>
+  </p:cSld>
+  <p:clrMapOvr>
+    <a:masterClrMapping/>
+  </p:clrMapOvr>
+</p:sld>
+</file>
+
 <file path=ppt/slides/slide2.xml><?xml version="1.0" encoding="utf-8"?>
 <p:sld xmlns:a="http://schemas.openxmlformats.org/drawingml/2006/main" xmlns:p="http://schemas.openxmlformats.org/presentationml/2006/main" xmlns:r="http://schemas.openxmlformats.org/officeDocument/2006/relationships">
   <p:cSld>
@@ -5179,7 +5640,7 @@
                 </a:solidFill>
                 <a:latin typeface="Calibri"/>
               </a:rPr>
-              <a:t>2 / 10</a:t>
+              <a:t>2 / 11</a:t>
             </a:r>
           </a:p>
         </p:txBody>
@@ -5679,7 +6140,7 @@
                 </a:solidFill>
                 <a:latin typeface="Calibri"/>
               </a:rPr>
-              <a:t>3 / 10</a:t>
+              <a:t>3 / 11</a:t>
             </a:r>
           </a:p>
         </p:txBody>
@@ -6348,7 +6809,7 @@
                 </a:solidFill>
                 <a:latin typeface="Calibri"/>
               </a:rPr>
-              <a:t>4 / 10</a:t>
+              <a:t>4 / 11</a:t>
             </a:r>
           </a:p>
         </p:txBody>
@@ -7270,7 +7731,7 @@
                 </a:solidFill>
                 <a:latin typeface="Calibri"/>
               </a:rPr>
-              <a:t>5 / 10</a:t>
+              <a:t>5 / 11</a:t>
             </a:r>
           </a:p>
         </p:txBody>
@@ -8104,7 +8565,7 @@
                 </a:solidFill>
                 <a:latin typeface="Calibri"/>
               </a:rPr>
-              <a:t>6 / 10</a:t>
+              <a:t>6 / 11</a:t>
             </a:r>
           </a:p>
         </p:txBody>
@@ -8851,849 +9312,6 @@
                 <a:latin typeface="Calibri"/>
               </a:rPr>
               <a:t>curl confirma HTTP 200. Si falla, el pipeline se detiene. Sin ambiguedad.</a:t>
-            </a:r>
-          </a:p>
-        </p:txBody>
-      </p:sp>
-    </p:spTree>
-  </p:cSld>
-  <p:clrMapOvr>
-    <a:masterClrMapping/>
-  </p:clrMapOvr>
-</p:sld>
-</file>
-
-<file path=ppt/slides/slide7.xml><?xml version="1.0" encoding="utf-8"?>
-<p:sld xmlns:a="http://schemas.openxmlformats.org/drawingml/2006/main" xmlns:p="http://schemas.openxmlformats.org/presentationml/2006/main" xmlns:r="http://schemas.openxmlformats.org/officeDocument/2006/relationships">
-  <p:cSld>
-    <p:spTree>
-      <p:nvGrpSpPr>
-        <p:cNvPr id="1" name=""/>
-        <p:cNvGrpSpPr/>
-        <p:nvPr/>
-      </p:nvGrpSpPr>
-      <p:grpSpPr/>
-      <p:sp>
-        <p:nvSpPr>
-          <p:cNvPr id="2" name="Rectangle 1"/>
-          <p:cNvSpPr/>
-          <p:nvPr/>
-        </p:nvSpPr>
-        <p:spPr>
-          <a:xfrm>
-            <a:off x="0" y="0"/>
-            <a:ext cx="12191695" cy="50292"/>
-          </a:xfrm>
-          <a:prstGeom prst="rect">
-            <a:avLst/>
-          </a:prstGeom>
-          <a:solidFill>
-            <a:srgbClr val="0F766E"/>
-          </a:solidFill>
-          <a:ln>
-            <a:noFill/>
-          </a:ln>
-          <a:effectLst/>
-        </p:spPr>
-        <p:style>
-          <a:lnRef idx="1">
-            <a:schemeClr val="accent1"/>
-          </a:lnRef>
-          <a:fillRef idx="3">
-            <a:schemeClr val="accent1"/>
-          </a:fillRef>
-          <a:effectRef idx="2">
-            <a:schemeClr val="accent1"/>
-          </a:effectRef>
-          <a:fontRef idx="minor">
-            <a:schemeClr val="lt1"/>
-          </a:fontRef>
-        </p:style>
-        <p:txBody>
-          <a:bodyPr rtlCol="0" anchor="ctr"/>
-          <a:lstStyle/>
-          <a:p>
-            <a:pPr algn="ctr"/>
-          </a:p>
-        </p:txBody>
-      </p:sp>
-      <p:sp>
-        <p:nvSpPr>
-          <p:cNvPr id="3" name="TextBox 2"/>
-          <p:cNvSpPr txBox="1"/>
-          <p:nvPr/>
-        </p:nvSpPr>
-        <p:spPr>
-          <a:xfrm>
-            <a:off x="411480" y="6510528"/>
-            <a:ext cx="6400800" cy="274320"/>
-          </a:xfrm>
-          <a:prstGeom prst="rect">
-            <a:avLst/>
-          </a:prstGeom>
-          <a:noFill/>
-        </p:spPr>
-        <p:txBody>
-          <a:bodyPr wrap="square" lIns="45720" rIns="45720" tIns="18288" bIns="18288" anchor="t">
-            <a:spAutoFit/>
-          </a:bodyPr>
-          <a:lstStyle/>
-          <a:p>
-            <a:pPr algn="l"/>
-            <a:r>
-              <a:rPr sz="1000" b="0" i="0">
-                <a:solidFill>
-                  <a:srgbClr val="64748B"/>
-                </a:solidFill>
-                <a:latin typeface="Calibri"/>
-              </a:rPr>
-              <a:t>Bootcamperu  ·  Masterclass CI/CD</a:t>
-            </a:r>
-          </a:p>
-        </p:txBody>
-      </p:sp>
-      <p:sp>
-        <p:nvSpPr>
-          <p:cNvPr id="4" name="TextBox 3"/>
-          <p:cNvSpPr txBox="1"/>
-          <p:nvPr/>
-        </p:nvSpPr>
-        <p:spPr>
-          <a:xfrm>
-            <a:off x="11274552" y="6510528"/>
-            <a:ext cx="548640" cy="274320"/>
-          </a:xfrm>
-          <a:prstGeom prst="rect">
-            <a:avLst/>
-          </a:prstGeom>
-          <a:noFill/>
-        </p:spPr>
-        <p:txBody>
-          <a:bodyPr wrap="square" lIns="45720" rIns="45720" tIns="18288" bIns="18288" anchor="t">
-            <a:spAutoFit/>
-          </a:bodyPr>
-          <a:lstStyle/>
-          <a:p>
-            <a:pPr algn="r"/>
-            <a:r>
-              <a:rPr sz="1000" b="1" i="0">
-                <a:solidFill>
-                  <a:srgbClr val="0F172A"/>
-                </a:solidFill>
-                <a:latin typeface="Calibri"/>
-              </a:rPr>
-              <a:t>7 / 10</a:t>
-            </a:r>
-          </a:p>
-        </p:txBody>
-      </p:sp>
-      <p:sp>
-        <p:nvSpPr>
-          <p:cNvPr id="5" name="Rectangle 4"/>
-          <p:cNvSpPr/>
-          <p:nvPr/>
-        </p:nvSpPr>
-        <p:spPr>
-          <a:xfrm>
-            <a:off x="411480" y="457200"/>
-            <a:ext cx="164592" cy="164592"/>
-          </a:xfrm>
-          <a:prstGeom prst="rect">
-            <a:avLst/>
-          </a:prstGeom>
-          <a:solidFill>
-            <a:srgbClr val="0F766E"/>
-          </a:solidFill>
-          <a:ln>
-            <a:noFill/>
-          </a:ln>
-          <a:effectLst/>
-        </p:spPr>
-        <p:style>
-          <a:lnRef idx="1">
-            <a:schemeClr val="accent1"/>
-          </a:lnRef>
-          <a:fillRef idx="3">
-            <a:schemeClr val="accent1"/>
-          </a:fillRef>
-          <a:effectRef idx="2">
-            <a:schemeClr val="accent1"/>
-          </a:effectRef>
-          <a:fontRef idx="minor">
-            <a:schemeClr val="lt1"/>
-          </a:fontRef>
-        </p:style>
-        <p:txBody>
-          <a:bodyPr rtlCol="0" anchor="ctr"/>
-          <a:lstStyle/>
-          <a:p>
-            <a:pPr algn="ctr"/>
-          </a:p>
-        </p:txBody>
-      </p:sp>
-      <p:sp>
-        <p:nvSpPr>
-          <p:cNvPr id="6" name="TextBox 5"/>
-          <p:cNvSpPr txBox="1"/>
-          <p:nvPr/>
-        </p:nvSpPr>
-        <p:spPr>
-          <a:xfrm>
-            <a:off x="685800" y="365760"/>
-            <a:ext cx="10972800" cy="365760"/>
-          </a:xfrm>
-          <a:prstGeom prst="rect">
-            <a:avLst/>
-          </a:prstGeom>
-          <a:noFill/>
-        </p:spPr>
-        <p:txBody>
-          <a:bodyPr wrap="square" lIns="45720" rIns="45720" tIns="18288" bIns="18288" anchor="t">
-            <a:spAutoFit/>
-          </a:bodyPr>
-          <a:lstStyle/>
-          <a:p>
-            <a:pPr algn="l"/>
-            <a:r>
-              <a:rPr sz="1300" b="1" i="0">
-                <a:solidFill>
-                  <a:srgbClr val="0F766E"/>
-                </a:solidFill>
-                <a:latin typeface="Calibri"/>
-              </a:rPr>
-              <a:t>ARQUITECTURA</a:t>
-            </a:r>
-          </a:p>
-        </p:txBody>
-      </p:sp>
-      <p:sp>
-        <p:nvSpPr>
-          <p:cNvPr id="7" name="TextBox 6"/>
-          <p:cNvSpPr txBox="1"/>
-          <p:nvPr/>
-        </p:nvSpPr>
-        <p:spPr>
-          <a:xfrm>
-            <a:off x="411480" y="777240"/>
-            <a:ext cx="11338560" cy="914400"/>
-          </a:xfrm>
-          <a:prstGeom prst="rect">
-            <a:avLst/>
-          </a:prstGeom>
-          <a:noFill/>
-        </p:spPr>
-        <p:txBody>
-          <a:bodyPr wrap="square" lIns="45720" rIns="45720" tIns="18288" bIns="18288" anchor="t">
-            <a:spAutoFit/>
-          </a:bodyPr>
-          <a:lstStyle/>
-          <a:p>
-            <a:pPr algn="l"/>
-            <a:r>
-              <a:rPr sz="3600" b="1" i="0">
-                <a:solidFill>
-                  <a:srgbClr val="0F172A"/>
-                </a:solidFill>
-                <a:latin typeface="Cambria"/>
-              </a:rPr>
-              <a:t>¿Que Construyo el Robot?</a:t>
-            </a:r>
-          </a:p>
-        </p:txBody>
-      </p:sp>
-      <p:sp>
-        <p:nvSpPr>
-          <p:cNvPr id="8" name="Rectangle 7"/>
-          <p:cNvSpPr/>
-          <p:nvPr/>
-        </p:nvSpPr>
-        <p:spPr>
-          <a:xfrm>
-            <a:off x="411480" y="1920240"/>
-            <a:ext cx="5394960" cy="292608"/>
-          </a:xfrm>
-          <a:prstGeom prst="rect">
-            <a:avLst/>
-          </a:prstGeom>
-          <a:solidFill>
-            <a:srgbClr val="0F766E"/>
-          </a:solidFill>
-          <a:ln>
-            <a:noFill/>
-          </a:ln>
-          <a:effectLst/>
-        </p:spPr>
-        <p:style>
-          <a:lnRef idx="1">
-            <a:schemeClr val="accent1"/>
-          </a:lnRef>
-          <a:fillRef idx="3">
-            <a:schemeClr val="accent1"/>
-          </a:fillRef>
-          <a:effectRef idx="2">
-            <a:schemeClr val="accent1"/>
-          </a:effectRef>
-          <a:fontRef idx="minor">
-            <a:schemeClr val="lt1"/>
-          </a:fontRef>
-        </p:style>
-        <p:txBody>
-          <a:bodyPr rtlCol="0" anchor="ctr"/>
-          <a:lstStyle/>
-          <a:p>
-            <a:pPr algn="ctr"/>
-          </a:p>
-        </p:txBody>
-      </p:sp>
-      <p:sp>
-        <p:nvSpPr>
-          <p:cNvPr id="9" name="TextBox 8"/>
-          <p:cNvSpPr txBox="1"/>
-          <p:nvPr/>
-        </p:nvSpPr>
-        <p:spPr>
-          <a:xfrm>
-            <a:off x="521208" y="1956816"/>
-            <a:ext cx="5175504" cy="228600"/>
-          </a:xfrm>
-          <a:prstGeom prst="rect">
-            <a:avLst/>
-          </a:prstGeom>
-          <a:noFill/>
-        </p:spPr>
-        <p:txBody>
-          <a:bodyPr wrap="square" lIns="45720" rIns="45720" tIns="18288" bIns="18288" anchor="t">
-            <a:spAutoFit/>
-          </a:bodyPr>
-          <a:lstStyle/>
-          <a:p>
-            <a:pPr algn="l"/>
-            <a:r>
-              <a:rPr sz="1000" b="1" i="0">
-                <a:solidFill>
-                  <a:srgbClr val="FFFFFF"/>
-                </a:solidFill>
-                <a:latin typeface="Consolas"/>
-              </a:rPr>
-              <a:t>Flujo del Pipeline  ·  alto nivel</a:t>
-            </a:r>
-          </a:p>
-        </p:txBody>
-      </p:sp>
-      <p:sp>
-        <p:nvSpPr>
-          <p:cNvPr id="10" name="Rectangle 9"/>
-          <p:cNvSpPr/>
-          <p:nvPr/>
-        </p:nvSpPr>
-        <p:spPr>
-          <a:xfrm>
-            <a:off x="411480" y="2212848"/>
-            <a:ext cx="5394960" cy="1993392"/>
-          </a:xfrm>
-          <a:prstGeom prst="rect">
-            <a:avLst/>
-          </a:prstGeom>
-          <a:solidFill>
-            <a:srgbClr val="0F172A"/>
-          </a:solidFill>
-          <a:ln>
-            <a:noFill/>
-          </a:ln>
-          <a:effectLst/>
-        </p:spPr>
-        <p:style>
-          <a:lnRef idx="1">
-            <a:schemeClr val="accent1"/>
-          </a:lnRef>
-          <a:fillRef idx="3">
-            <a:schemeClr val="accent1"/>
-          </a:fillRef>
-          <a:effectRef idx="2">
-            <a:schemeClr val="accent1"/>
-          </a:effectRef>
-          <a:fontRef idx="minor">
-            <a:schemeClr val="lt1"/>
-          </a:fontRef>
-        </p:style>
-        <p:txBody>
-          <a:bodyPr rtlCol="0" anchor="ctr"/>
-          <a:lstStyle/>
-          <a:p>
-            <a:pPr algn="ctr"/>
-          </a:p>
-        </p:txBody>
-      </p:sp>
-      <p:sp>
-        <p:nvSpPr>
-          <p:cNvPr id="11" name="TextBox 10"/>
-          <p:cNvSpPr txBox="1"/>
-          <p:nvPr/>
-        </p:nvSpPr>
-        <p:spPr>
-          <a:xfrm>
-            <a:off x="548640" y="2286000"/>
-            <a:ext cx="5120640" cy="1874519"/>
-          </a:xfrm>
-          <a:prstGeom prst="rect">
-            <a:avLst/>
-          </a:prstGeom>
-          <a:noFill/>
-        </p:spPr>
-        <p:txBody>
-          <a:bodyPr wrap="square" lIns="45720" rIns="45720" tIns="18288" bIns="18288" anchor="t">
-            <a:spAutoFit/>
-          </a:bodyPr>
-          <a:lstStyle/>
-          <a:p>
-            <a:pPr algn="l"/>
-            <a:r>
-              <a:rPr sz="1100" b="0" i="0">
-                <a:solidFill>
-                  <a:srgbClr val="CBD5E1"/>
-                </a:solidFill>
-                <a:latin typeface="Consolas"/>
-              </a:rPr>
-              <a:t>Desarrollador</a:t>
-            </a:r>
-          </a:p>
-          <a:p>
-            <a:pPr algn="l"/>
-            <a:r>
-              <a:rPr sz="1100" b="0" i="0">
-                <a:solidFill>
-                  <a:srgbClr val="CBD5E1"/>
-                </a:solidFill>
-                <a:latin typeface="Consolas"/>
-              </a:rPr>
-              <a:t>  |  git push</a:t>
-            </a:r>
-          </a:p>
-          <a:p>
-            <a:pPr algn="l"/>
-            <a:r>
-              <a:rPr sz="1100" b="0" i="0">
-                <a:solidFill>
-                  <a:srgbClr val="CBD5E1"/>
-                </a:solidFill>
-                <a:latin typeface="Consolas"/>
-              </a:rPr>
-              <a:t>GitHub Actions</a:t>
-            </a:r>
-          </a:p>
-          <a:p>
-            <a:pPr algn="l"/>
-            <a:r>
-              <a:rPr sz="1100" b="0" i="0">
-                <a:solidFill>
-                  <a:srgbClr val="CBD5E1"/>
-                </a:solidFill>
-                <a:latin typeface="Consolas"/>
-              </a:rPr>
-              <a:t>  |  terraform apply</a:t>
-            </a:r>
-          </a:p>
-          <a:p>
-            <a:pPr algn="l"/>
-            <a:r>
-              <a:rPr sz="1100" b="0" i="0">
-                <a:solidFill>
-                  <a:srgbClr val="CBD5E1"/>
-                </a:solidFill>
-                <a:latin typeface="Consolas"/>
-              </a:rPr>
-              <a:t>AWS: VPC + EC2 + SGs</a:t>
-            </a:r>
-          </a:p>
-          <a:p>
-            <a:pPr algn="l"/>
-            <a:r>
-              <a:rPr sz="1100" b="0" i="0">
-                <a:solidFill>
-                  <a:srgbClr val="CBD5E1"/>
-                </a:solidFill>
-                <a:latin typeface="Consolas"/>
-              </a:rPr>
-              <a:t>  |  ansible-playbook</a:t>
-            </a:r>
-          </a:p>
-          <a:p>
-            <a:pPr algn="l"/>
-            <a:r>
-              <a:rPr sz="1100" b="0" i="0">
-                <a:solidFill>
-                  <a:srgbClr val="CBD5E1"/>
-                </a:solidFill>
-                <a:latin typeface="Consolas"/>
-              </a:rPr>
-              <a:t>App en produccion</a:t>
-            </a:r>
-          </a:p>
-        </p:txBody>
-      </p:sp>
-      <p:sp>
-        <p:nvSpPr>
-          <p:cNvPr id="12" name="Rectangle 11"/>
-          <p:cNvSpPr/>
-          <p:nvPr/>
-        </p:nvSpPr>
-        <p:spPr>
-          <a:xfrm>
-            <a:off x="6382512" y="1920240"/>
-            <a:ext cx="5394960" cy="292608"/>
-          </a:xfrm>
-          <a:prstGeom prst="rect">
-            <a:avLst/>
-          </a:prstGeom>
-          <a:solidFill>
-            <a:srgbClr val="C2410C"/>
-          </a:solidFill>
-          <a:ln>
-            <a:noFill/>
-          </a:ln>
-          <a:effectLst/>
-        </p:spPr>
-        <p:style>
-          <a:lnRef idx="1">
-            <a:schemeClr val="accent1"/>
-          </a:lnRef>
-          <a:fillRef idx="3">
-            <a:schemeClr val="accent1"/>
-          </a:fillRef>
-          <a:effectRef idx="2">
-            <a:schemeClr val="accent1"/>
-          </a:effectRef>
-          <a:fontRef idx="minor">
-            <a:schemeClr val="lt1"/>
-          </a:fontRef>
-        </p:style>
-        <p:txBody>
-          <a:bodyPr rtlCol="0" anchor="ctr"/>
-          <a:lstStyle/>
-          <a:p>
-            <a:pPr algn="ctr"/>
-          </a:p>
-        </p:txBody>
-      </p:sp>
-      <p:sp>
-        <p:nvSpPr>
-          <p:cNvPr id="13" name="TextBox 12"/>
-          <p:cNvSpPr txBox="1"/>
-          <p:nvPr/>
-        </p:nvSpPr>
-        <p:spPr>
-          <a:xfrm>
-            <a:off x="6492240" y="1956816"/>
-            <a:ext cx="5175504" cy="228600"/>
-          </a:xfrm>
-          <a:prstGeom prst="rect">
-            <a:avLst/>
-          </a:prstGeom>
-          <a:noFill/>
-        </p:spPr>
-        <p:txBody>
-          <a:bodyPr wrap="square" lIns="45720" rIns="45720" tIns="18288" bIns="18288" anchor="t">
-            <a:spAutoFit/>
-          </a:bodyPr>
-          <a:lstStyle/>
-          <a:p>
-            <a:pPr algn="l"/>
-            <a:r>
-              <a:rPr sz="1000" b="1" i="0">
-                <a:solidFill>
-                  <a:srgbClr val="FFFFFF"/>
-                </a:solidFill>
-                <a:latin typeface="Consolas"/>
-              </a:rPr>
-              <a:t>Red Interior AWS  ·  VPC</a:t>
-            </a:r>
-          </a:p>
-        </p:txBody>
-      </p:sp>
-      <p:sp>
-        <p:nvSpPr>
-          <p:cNvPr id="14" name="Rectangle 13"/>
-          <p:cNvSpPr/>
-          <p:nvPr/>
-        </p:nvSpPr>
-        <p:spPr>
-          <a:xfrm>
-            <a:off x="6382512" y="2212848"/>
-            <a:ext cx="5394960" cy="1993392"/>
-          </a:xfrm>
-          <a:prstGeom prst="rect">
-            <a:avLst/>
-          </a:prstGeom>
-          <a:solidFill>
-            <a:srgbClr val="0F172A"/>
-          </a:solidFill>
-          <a:ln>
-            <a:noFill/>
-          </a:ln>
-          <a:effectLst/>
-        </p:spPr>
-        <p:style>
-          <a:lnRef idx="1">
-            <a:schemeClr val="accent1"/>
-          </a:lnRef>
-          <a:fillRef idx="3">
-            <a:schemeClr val="accent1"/>
-          </a:fillRef>
-          <a:effectRef idx="2">
-            <a:schemeClr val="accent1"/>
-          </a:effectRef>
-          <a:fontRef idx="minor">
-            <a:schemeClr val="lt1"/>
-          </a:fontRef>
-        </p:style>
-        <p:txBody>
-          <a:bodyPr rtlCol="0" anchor="ctr"/>
-          <a:lstStyle/>
-          <a:p>
-            <a:pPr algn="ctr"/>
-          </a:p>
-        </p:txBody>
-      </p:sp>
-      <p:sp>
-        <p:nvSpPr>
-          <p:cNvPr id="15" name="TextBox 14"/>
-          <p:cNvSpPr txBox="1"/>
-          <p:nvPr/>
-        </p:nvSpPr>
-        <p:spPr>
-          <a:xfrm>
-            <a:off x="6519672" y="2286000"/>
-            <a:ext cx="5120640" cy="1874519"/>
-          </a:xfrm>
-          <a:prstGeom prst="rect">
-            <a:avLst/>
-          </a:prstGeom>
-          <a:noFill/>
-        </p:spPr>
-        <p:txBody>
-          <a:bodyPr wrap="square" lIns="45720" rIns="45720" tIns="18288" bIns="18288" anchor="t">
-            <a:spAutoFit/>
-          </a:bodyPr>
-          <a:lstStyle/>
-          <a:p>
-            <a:pPr algn="l"/>
-            <a:r>
-              <a:rPr sz="1100" b="0" i="0">
-                <a:solidFill>
-                  <a:srgbClr val="CBD5E1"/>
-                </a:solidFill>
-                <a:latin typeface="Consolas"/>
-              </a:rPr>
-              <a:t>Internet</a:t>
-            </a:r>
-          </a:p>
-          <a:p>
-            <a:pPr algn="l"/>
-            <a:r>
-              <a:rPr sz="1100" b="0" i="0">
-                <a:solidFill>
-                  <a:srgbClr val="CBD5E1"/>
-                </a:solidFill>
-                <a:latin typeface="Consolas"/>
-              </a:rPr>
-              <a:t>  |  Puerto 80</a:t>
-            </a:r>
-          </a:p>
-          <a:p>
-            <a:pPr algn="l"/>
-            <a:r>
-              <a:rPr sz="1100" b="0" i="0">
-                <a:solidFill>
-                  <a:srgbClr val="CBD5E1"/>
-                </a:solidFill>
-                <a:latin typeface="Consolas"/>
-              </a:rPr>
-              <a:t>Nginx (Subred Publica)</a:t>
-            </a:r>
-          </a:p>
-          <a:p>
-            <a:pPr algn="l"/>
-            <a:r>
-              <a:rPr sz="1100" b="0" i="0">
-                <a:solidFill>
-                  <a:srgbClr val="CBD5E1"/>
-                </a:solidFill>
-                <a:latin typeface="Consolas"/>
-              </a:rPr>
-              <a:t>  |  proxy_pass :5000</a:t>
-            </a:r>
-          </a:p>
-          <a:p>
-            <a:pPr algn="l"/>
-            <a:r>
-              <a:rPr sz="1100" b="0" i="0">
-                <a:solidFill>
-                  <a:srgbClr val="CBD5E1"/>
-                </a:solidFill>
-                <a:latin typeface="Consolas"/>
-              </a:rPr>
-              <a:t>FastAPI (Subred Privada)</a:t>
-            </a:r>
-          </a:p>
-          <a:p>
-            <a:pPr algn="l"/>
-            <a:r>
-              <a:rPr sz="1100" b="0" i="0">
-                <a:solidFill>
-                  <a:srgbClr val="CBD5E1"/>
-                </a:solidFill>
-                <a:latin typeface="Consolas"/>
-              </a:rPr>
-              <a:t>  (sin IP publica)</a:t>
-            </a:r>
-          </a:p>
-        </p:txBody>
-      </p:sp>
-      <p:sp>
-        <p:nvSpPr>
-          <p:cNvPr id="16" name="Rectangle 15"/>
-          <p:cNvSpPr/>
-          <p:nvPr/>
-        </p:nvSpPr>
-        <p:spPr>
-          <a:xfrm>
-            <a:off x="411480" y="4389120"/>
-            <a:ext cx="11365992" cy="914400"/>
-          </a:xfrm>
-          <a:prstGeom prst="rect">
-            <a:avLst/>
-          </a:prstGeom>
-          <a:solidFill>
-            <a:srgbClr val="F0FDFA"/>
-          </a:solidFill>
-          <a:ln>
-            <a:noFill/>
-          </a:ln>
-          <a:effectLst/>
-        </p:spPr>
-        <p:style>
-          <a:lnRef idx="1">
-            <a:schemeClr val="accent1"/>
-          </a:lnRef>
-          <a:fillRef idx="3">
-            <a:schemeClr val="accent1"/>
-          </a:fillRef>
-          <a:effectRef idx="2">
-            <a:schemeClr val="accent1"/>
-          </a:effectRef>
-          <a:fontRef idx="minor">
-            <a:schemeClr val="lt1"/>
-          </a:fontRef>
-        </p:style>
-        <p:txBody>
-          <a:bodyPr rtlCol="0" anchor="ctr"/>
-          <a:lstStyle/>
-          <a:p>
-            <a:pPr algn="ctr"/>
-          </a:p>
-        </p:txBody>
-      </p:sp>
-      <p:sp>
-        <p:nvSpPr>
-          <p:cNvPr id="17" name="TextBox 16"/>
-          <p:cNvSpPr txBox="1"/>
-          <p:nvPr/>
-        </p:nvSpPr>
-        <p:spPr>
-          <a:xfrm>
-            <a:off x="640080" y="4526280"/>
-            <a:ext cx="11000232" cy="292608"/>
-          </a:xfrm>
-          <a:prstGeom prst="rect">
-            <a:avLst/>
-          </a:prstGeom>
-          <a:noFill/>
-        </p:spPr>
-        <p:txBody>
-          <a:bodyPr wrap="square" lIns="45720" rIns="45720" tIns="18288" bIns="18288" anchor="t">
-            <a:spAutoFit/>
-          </a:bodyPr>
-          <a:lstStyle/>
-          <a:p>
-            <a:pPr algn="l"/>
-            <a:r>
-              <a:rPr sz="1200" b="1" i="0">
-                <a:solidFill>
-                  <a:srgbClr val="0F766E"/>
-                </a:solidFill>
-                <a:latin typeface="Calibri"/>
-              </a:rPr>
-              <a:t>El aislamiento clave:</a:t>
-            </a:r>
-          </a:p>
-        </p:txBody>
-      </p:sp>
-      <p:sp>
-        <p:nvSpPr>
-          <p:cNvPr id="18" name="TextBox 17"/>
-          <p:cNvSpPr txBox="1"/>
-          <p:nvPr/>
-        </p:nvSpPr>
-        <p:spPr>
-          <a:xfrm>
-            <a:off x="640080" y="4846320"/>
-            <a:ext cx="11000232" cy="365760"/>
-          </a:xfrm>
-          <a:prstGeom prst="rect">
-            <a:avLst/>
-          </a:prstGeom>
-          <a:noFill/>
-        </p:spPr>
-        <p:txBody>
-          <a:bodyPr wrap="square" lIns="45720" rIns="45720" tIns="18288" bIns="18288" anchor="t">
-            <a:spAutoFit/>
-          </a:bodyPr>
-          <a:lstStyle/>
-          <a:p>
-            <a:pPr algn="l"/>
-            <a:r>
-              <a:rPr sz="1200" b="0" i="0">
-                <a:solidFill>
-                  <a:srgbClr val="334155"/>
-                </a:solidFill>
-                <a:latin typeface="Calibri"/>
-              </a:rPr>
-              <a:t>El backend no tiene IP publica. Solo Nginx puede hablarle en el puerto 5000. El Security Group rechaza cualquier otro trafico.</a:t>
-            </a:r>
-          </a:p>
-        </p:txBody>
-      </p:sp>
-      <p:sp>
-        <p:nvSpPr>
-          <p:cNvPr id="19" name="TextBox 18"/>
-          <p:cNvSpPr txBox="1"/>
-          <p:nvPr/>
-        </p:nvSpPr>
-        <p:spPr>
-          <a:xfrm>
-            <a:off x="411480" y="5486400"/>
-            <a:ext cx="11365992" cy="457200"/>
-          </a:xfrm>
-          <a:prstGeom prst="rect">
-            <a:avLst/>
-          </a:prstGeom>
-          <a:noFill/>
-        </p:spPr>
-        <p:txBody>
-          <a:bodyPr wrap="square" lIns="45720" rIns="45720" tIns="18288" bIns="18288" anchor="t">
-            <a:spAutoFit/>
-          </a:bodyPr>
-          <a:lstStyle/>
-          <a:p>
-            <a:pPr algn="l"/>
-            <a:r>
-              <a:rPr sz="1100" b="0" i="1">
-                <a:solidFill>
-                  <a:srgbClr val="64748B"/>
-                </a:solidFill>
-                <a:latin typeface="Calibri"/>
-              </a:rPr>
-              <a:t>Los diagramas Excalidraw del repositorio muestran esto con detalle.</a:t>
             </a:r>
           </a:p>
         </p:txBody>
@@ -9825,7 +9443,7 @@
                 </a:solidFill>
                 <a:latin typeface="Calibri"/>
               </a:rPr>
-              <a:t>8 / 10</a:t>
+              <a:t>9 / 11</a:t>
             </a:r>
           </a:p>
         </p:txBody>
@@ -10391,7 +10009,7 @@
                 </a:solidFill>
                 <a:latin typeface="Calibri"/>
               </a:rPr>
-              <a:t>9 / 10</a:t>
+              <a:t>10 / 11</a:t>
             </a:r>
           </a:p>
         </p:txBody>

</xml_diff>

<commit_message>
chore(diagramas): re-exportar tldraw y refrescar imagenes en PPTX
</commit_message>
<xml_diff>
--- a/presentation/final_presentation.pptx
+++ b/presentation/final_presentation.pptx
@@ -10670,7 +10670,7 @@
       </p:sp>
       <p:pic>
         <p:nvPicPr>
-          <p:cNvPr id="8" name="Picture 7" descr="pipeline_flow.png"/>
+          <p:cNvPr id="8" name="Picture 7" descr="image.png"/>
           <p:cNvPicPr>
             <a:picLocks noChangeAspect="1"/>
           </p:cNvPicPr>
@@ -10949,7 +10949,7 @@
       </p:sp>
       <p:pic>
         <p:nvPicPr>
-          <p:cNvPr id="8" name="Picture 7" descr="cloud_interior.png"/>
+          <p:cNvPr id="8" name="Picture 7" descr="image.png"/>
           <p:cNvPicPr>
             <a:picLocks noChangeAspect="1"/>
           </p:cNvPicPr>

</xml_diff>